<commit_message>
Move os icones de linha da pagina F&I para a icons_bain
A pagina passa a puxar os icones da biblioteca compartilhada, como o deck
de lead quente: a familia `*_linha` (banco, carro, pessoas, engrenagem,
monitor, rede) entra ao lado dos icones cheios, um estilo por pagina.

Co-Authored-By: Claude Opus 5 <noreply@anthropic.com>
Claude-Session: https://claude.ai/code/session_01Ua7ZG6roqduHYUfSPaf4r8
</commit_message>
<xml_diff>
--- a/output/fmi_multibanco.pptx
+++ b/output/fmi_multibanco.pptx
@@ -3462,29 +3462,16 @@
             <a:avLst/>
           </a:prstGeom>
           <a:noFill/>
-          <a:ln w="19482">
+          <a:ln w="19482" cap="rnd">
             <a:solidFill>
               <a:srgbClr val="BC1227"/>
             </a:solidFill>
+            <a:round/>
           </a:ln>
           <a:effectLst/>
         </p:spPr>
-        <p:style>
-          <a:lnRef idx="1">
-            <a:schemeClr val="accent1"/>
-          </a:lnRef>
-          <a:fillRef idx="3">
-            <a:schemeClr val="accent1"/>
-          </a:fillRef>
-          <a:effectRef idx="2">
-            <a:schemeClr val="accent1"/>
-          </a:effectRef>
-          <a:fontRef idx="minor">
-            <a:schemeClr val="lt1"/>
-          </a:fontRef>
-        </p:style>
-        <p:txBody>
-          <a:bodyPr rtlCol="0" anchor="ctr"/>
+        <p:txBody>
+          <a:bodyPr rtlCol="0" anchor="ctr" wrap="square"/>
           <a:lstStyle/>
           <a:p>
             <a:pPr algn="ctr"/>
@@ -3506,29 +3493,16 @@
             <a:avLst/>
           </a:prstGeom>
           <a:noFill/>
-          <a:ln w="19482">
+          <a:ln w="19482" cap="rnd">
             <a:solidFill>
               <a:srgbClr val="BC1227"/>
             </a:solidFill>
+            <a:round/>
           </a:ln>
           <a:effectLst/>
         </p:spPr>
-        <p:style>
-          <a:lnRef idx="1">
-            <a:schemeClr val="accent1"/>
-          </a:lnRef>
-          <a:fillRef idx="3">
-            <a:schemeClr val="accent1"/>
-          </a:fillRef>
-          <a:effectRef idx="2">
-            <a:schemeClr val="accent1"/>
-          </a:effectRef>
-          <a:fontRef idx="minor">
-            <a:schemeClr val="lt1"/>
-          </a:fontRef>
-        </p:style>
-        <p:txBody>
-          <a:bodyPr rtlCol="0" anchor="ctr"/>
+        <p:txBody>
+          <a:bodyPr rtlCol="0" anchor="ctr" wrap="square"/>
           <a:lstStyle/>
           <a:p>
             <a:pPr algn="ctr"/>
@@ -3544,7 +3518,7 @@
         <p:spPr>
           <a:xfrm>
             <a:off x="2627282" y="2597727"/>
-            <a:ext cx="155863" cy="87673"/>
+            <a:ext cx="155864" cy="87674"/>
           </a:xfrm>
           <a:custGeom>
             <a:avLst/>
@@ -3553,36 +3527,36 @@
             <a:cxnLst/>
             <a:rect l="l" t="t" r="r" b="b"/>
             <a:pathLst>
-              <a:path w="155863" h="87673">
+              <a:path w="155864" h="87674">
                 <a:moveTo>
-                  <a:pt x="0" y="87673"/>
+                  <a:pt x="0" y="87674"/>
                 </a:moveTo>
                 <a:lnTo>
                   <a:pt x="1482" y="75596"/>
                 </a:lnTo>
                 <a:lnTo>
-                  <a:pt x="3805" y="64413"/>
-                </a:lnTo>
-                <a:lnTo>
-                  <a:pt x="6917" y="54125"/>
-                </a:lnTo>
-                <a:lnTo>
-                  <a:pt x="10764" y="44731"/>
-                </a:lnTo>
-                <a:lnTo>
-                  <a:pt x="15292" y="36232"/>
-                </a:lnTo>
-                <a:lnTo>
-                  <a:pt x="20448" y="28628"/>
-                </a:lnTo>
-                <a:lnTo>
-                  <a:pt x="26180" y="21918"/>
-                </a:lnTo>
-                <a:lnTo>
-                  <a:pt x="32433" y="16103"/>
-                </a:lnTo>
-                <a:lnTo>
-                  <a:pt x="39155" y="11183"/>
+                  <a:pt x="3806" y="64413"/>
+                </a:lnTo>
+                <a:lnTo>
+                  <a:pt x="6918" y="54125"/>
+                </a:lnTo>
+                <a:lnTo>
+                  <a:pt x="10764" y="44732"/>
+                </a:lnTo>
+                <a:lnTo>
+                  <a:pt x="15292" y="36233"/>
+                </a:lnTo>
+                <a:lnTo>
+                  <a:pt x="20449" y="28628"/>
+                </a:lnTo>
+                <a:lnTo>
+                  <a:pt x="26180" y="21919"/>
+                </a:lnTo>
+                <a:lnTo>
+                  <a:pt x="32434" y="16104"/>
+                </a:lnTo>
+                <a:lnTo>
+                  <a:pt x="39156" y="11183"/>
                 </a:lnTo>
                 <a:lnTo>
                   <a:pt x="46293" y="7157"/>
@@ -3591,43 +3565,43 @@
                   <a:pt x="53793" y="4026"/>
                 </a:lnTo>
                 <a:lnTo>
-                  <a:pt x="61601" y="1789"/>
-                </a:lnTo>
-                <a:lnTo>
-                  <a:pt x="69665" y="447"/>
-                </a:lnTo>
-                <a:lnTo>
-                  <a:pt x="77931" y="0"/>
-                </a:lnTo>
-                <a:lnTo>
-                  <a:pt x="86198" y="447"/>
-                </a:lnTo>
-                <a:lnTo>
-                  <a:pt x="94262" y="1789"/>
-                </a:lnTo>
-                <a:lnTo>
-                  <a:pt x="102070" y="4026"/>
+                  <a:pt x="61602" y="1790"/>
+                </a:lnTo>
+                <a:lnTo>
+                  <a:pt x="69666" y="448"/>
+                </a:lnTo>
+                <a:lnTo>
+                  <a:pt x="77932" y="0"/>
+                </a:lnTo>
+                <a:lnTo>
+                  <a:pt x="86198" y="448"/>
+                </a:lnTo>
+                <a:lnTo>
+                  <a:pt x="94262" y="1790"/>
+                </a:lnTo>
+                <a:lnTo>
+                  <a:pt x="102071" y="4026"/>
                 </a:lnTo>
                 <a:lnTo>
                   <a:pt x="109570" y="7157"/>
                 </a:lnTo>
                 <a:lnTo>
-                  <a:pt x="116707" y="11183"/>
-                </a:lnTo>
-                <a:lnTo>
-                  <a:pt x="123430" y="16103"/>
-                </a:lnTo>
-                <a:lnTo>
-                  <a:pt x="129683" y="21918"/>
+                  <a:pt x="116708" y="11183"/>
+                </a:lnTo>
+                <a:lnTo>
+                  <a:pt x="123430" y="16104"/>
+                </a:lnTo>
+                <a:lnTo>
+                  <a:pt x="129684" y="21919"/>
                 </a:lnTo>
                 <a:lnTo>
                   <a:pt x="135415" y="28628"/>
                 </a:lnTo>
                 <a:lnTo>
-                  <a:pt x="140571" y="36232"/>
-                </a:lnTo>
-                <a:lnTo>
-                  <a:pt x="145099" y="44731"/>
+                  <a:pt x="140572" y="36233"/>
+                </a:lnTo>
+                <a:lnTo>
+                  <a:pt x="145100" y="44732"/>
                 </a:lnTo>
                 <a:lnTo>
                   <a:pt x="148946" y="54125"/>
@@ -3636,38 +3610,25 @@
                   <a:pt x="152058" y="64413"/>
                 </a:lnTo>
                 <a:lnTo>
-                  <a:pt x="154381" y="75596"/>
-                </a:lnTo>
-                <a:lnTo>
-                  <a:pt x="155863" y="87673"/>
+                  <a:pt x="154382" y="75596"/>
+                </a:lnTo>
+                <a:lnTo>
+                  <a:pt x="155864" y="87674"/>
                 </a:lnTo>
               </a:path>
             </a:pathLst>
           </a:custGeom>
           <a:noFill/>
-          <a:ln w="19482">
+          <a:ln w="19482" cap="rnd">
             <a:solidFill>
               <a:srgbClr val="BC1227"/>
             </a:solidFill>
+            <a:round/>
           </a:ln>
           <a:effectLst/>
         </p:spPr>
-        <p:style>
-          <a:lnRef idx="1">
-            <a:schemeClr val="accent1"/>
-          </a:lnRef>
-          <a:fillRef idx="3">
-            <a:schemeClr val="accent1"/>
-          </a:fillRef>
-          <a:effectRef idx="2">
-            <a:schemeClr val="accent1"/>
-          </a:effectRef>
-          <a:fontRef idx="minor">
-            <a:schemeClr val="lt1"/>
-          </a:fontRef>
-        </p:style>
-        <p:txBody>
-          <a:bodyPr rtlCol="0" anchor="ctr"/>
+        <p:txBody>
+          <a:bodyPr rtlCol="0" anchor="ctr" wrap="square"/>
           <a:lstStyle/>
           <a:p>
             <a:pPr algn="ctr"/>
@@ -3683,7 +3644,7 @@
         <p:spPr>
           <a:xfrm>
             <a:off x="2714955" y="2612339"/>
-            <a:ext cx="136381" cy="73061"/>
+            <a:ext cx="136381" cy="73062"/>
           </a:xfrm>
           <a:custGeom>
             <a:avLst/>
@@ -3692,121 +3653,108 @@
             <a:cxnLst/>
             <a:rect l="l" t="t" r="r" b="b"/>
             <a:pathLst>
-              <a:path w="136381" h="73061">
+              <a:path w="136381" h="73062">
                 <a:moveTo>
-                  <a:pt x="0" y="73061"/>
+                  <a:pt x="0" y="73062"/>
                 </a:moveTo>
                 <a:lnTo>
-                  <a:pt x="1409" y="62997"/>
+                  <a:pt x="1410" y="62997"/>
                 </a:lnTo>
                 <a:lnTo>
                   <a:pt x="3522" y="53678"/>
                 </a:lnTo>
                 <a:lnTo>
-                  <a:pt x="6294" y="45104"/>
-                </a:lnTo>
-                <a:lnTo>
-                  <a:pt x="9685" y="37276"/>
-                </a:lnTo>
-                <a:lnTo>
-                  <a:pt x="13650" y="30194"/>
-                </a:lnTo>
-                <a:lnTo>
-                  <a:pt x="18148" y="23857"/>
-                </a:lnTo>
-                <a:lnTo>
-                  <a:pt x="23136" y="18265"/>
-                </a:lnTo>
-                <a:lnTo>
-                  <a:pt x="28571" y="13419"/>
-                </a:lnTo>
-                <a:lnTo>
-                  <a:pt x="34411" y="9319"/>
-                </a:lnTo>
-                <a:lnTo>
-                  <a:pt x="40613" y="5964"/>
+                  <a:pt x="6295" y="45105"/>
+                </a:lnTo>
+                <a:lnTo>
+                  <a:pt x="9685" y="37277"/>
+                </a:lnTo>
+                <a:lnTo>
+                  <a:pt x="13651" y="30194"/>
+                </a:lnTo>
+                <a:lnTo>
+                  <a:pt x="18149" y="23857"/>
+                </a:lnTo>
+                <a:lnTo>
+                  <a:pt x="23136" y="18266"/>
+                </a:lnTo>
+                <a:lnTo>
+                  <a:pt x="28572" y="13420"/>
+                </a:lnTo>
+                <a:lnTo>
+                  <a:pt x="34412" y="9320"/>
+                </a:lnTo>
+                <a:lnTo>
+                  <a:pt x="40614" y="5965"/>
                 </a:lnTo>
                 <a:lnTo>
                   <a:pt x="47135" y="3355"/>
                 </a:lnTo>
                 <a:lnTo>
-                  <a:pt x="53933" y="1491"/>
+                  <a:pt x="53934" y="1492"/>
                 </a:lnTo>
                 <a:lnTo>
                   <a:pt x="60966" y="373"/>
                 </a:lnTo>
                 <a:lnTo>
-                  <a:pt x="68190" y="0"/>
+                  <a:pt x="68191" y="0"/>
                 </a:lnTo>
                 <a:lnTo>
                   <a:pt x="75415" y="373"/>
                 </a:lnTo>
                 <a:lnTo>
-                  <a:pt x="82447" y="1491"/>
+                  <a:pt x="82448" y="1492"/>
                 </a:lnTo>
                 <a:lnTo>
                   <a:pt x="89246" y="3355"/>
                 </a:lnTo>
                 <a:lnTo>
-                  <a:pt x="95767" y="5964"/>
-                </a:lnTo>
-                <a:lnTo>
-                  <a:pt x="101969" y="9319"/>
-                </a:lnTo>
-                <a:lnTo>
-                  <a:pt x="107809" y="13419"/>
-                </a:lnTo>
-                <a:lnTo>
-                  <a:pt x="113245" y="18265"/>
+                  <a:pt x="95768" y="5965"/>
+                </a:lnTo>
+                <a:lnTo>
+                  <a:pt x="101970" y="9320"/>
+                </a:lnTo>
+                <a:lnTo>
+                  <a:pt x="107810" y="13420"/>
+                </a:lnTo>
+                <a:lnTo>
+                  <a:pt x="113245" y="18266"/>
                 </a:lnTo>
                 <a:lnTo>
                   <a:pt x="118233" y="23857"/>
                 </a:lnTo>
                 <a:lnTo>
-                  <a:pt x="122730" y="30194"/>
-                </a:lnTo>
-                <a:lnTo>
-                  <a:pt x="126696" y="37276"/>
-                </a:lnTo>
-                <a:lnTo>
-                  <a:pt x="130086" y="45104"/>
+                  <a:pt x="122731" y="30194"/>
+                </a:lnTo>
+                <a:lnTo>
+                  <a:pt x="126696" y="37277"/>
+                </a:lnTo>
+                <a:lnTo>
+                  <a:pt x="130087" y="45105"/>
                 </a:lnTo>
                 <a:lnTo>
                   <a:pt x="132859" y="53678"/>
                 </a:lnTo>
                 <a:lnTo>
-                  <a:pt x="134971" y="62997"/>
-                </a:lnTo>
-                <a:lnTo>
-                  <a:pt x="136381" y="73061"/>
+                  <a:pt x="134972" y="62997"/>
+                </a:lnTo>
+                <a:lnTo>
+                  <a:pt x="136381" y="73062"/>
                 </a:lnTo>
               </a:path>
             </a:pathLst>
           </a:custGeom>
           <a:noFill/>
-          <a:ln w="19482">
+          <a:ln w="19482" cap="rnd">
             <a:solidFill>
               <a:srgbClr val="BC1227"/>
             </a:solidFill>
+            <a:round/>
           </a:ln>
           <a:effectLst/>
         </p:spPr>
-        <p:style>
-          <a:lnRef idx="1">
-            <a:schemeClr val="accent1"/>
-          </a:lnRef>
-          <a:fillRef idx="3">
-            <a:schemeClr val="accent1"/>
-          </a:fillRef>
-          <a:effectRef idx="2">
-            <a:schemeClr val="accent1"/>
-          </a:effectRef>
-          <a:fontRef idx="minor">
-            <a:schemeClr val="lt1"/>
-          </a:fontRef>
-        </p:style>
-        <p:txBody>
-          <a:bodyPr rtlCol="0" anchor="ctr"/>
+        <p:txBody>
+          <a:bodyPr rtlCol="0" anchor="ctr" wrap="square"/>
           <a:lstStyle/>
           <a:p>
             <a:pPr algn="ctr"/>
@@ -3924,7 +3872,7 @@
         <p:spPr>
           <a:xfrm>
             <a:off x="5796155" y="2558761"/>
-            <a:ext cx="233795" cy="126639"/>
+            <a:ext cx="233796" cy="126640"/>
           </a:xfrm>
           <a:custGeom>
             <a:avLst/>
@@ -3933,42 +3881,42 @@
             <a:cxnLst/>
             <a:rect l="l" t="t" r="r" b="b"/>
             <a:pathLst>
-              <a:path w="233795" h="126639">
+              <a:path w="233796" h="126640">
                 <a:moveTo>
-                  <a:pt x="0" y="68190"/>
+                  <a:pt x="0" y="68191"/>
                 </a:moveTo>
                 <a:lnTo>
-                  <a:pt x="29224" y="0"/>
+                  <a:pt x="29225" y="0"/>
                 </a:lnTo>
                 <a:lnTo>
                   <a:pt x="204571" y="0"/>
                 </a:lnTo>
                 <a:lnTo>
-                  <a:pt x="233795" y="68190"/>
-                </a:lnTo>
-                <a:lnTo>
-                  <a:pt x="233795" y="126639"/>
-                </a:lnTo>
-                <a:lnTo>
-                  <a:pt x="204571" y="126639"/>
-                </a:lnTo>
-                <a:lnTo>
-                  <a:pt x="203243" y="116554"/>
-                </a:lnTo>
-                <a:lnTo>
-                  <a:pt x="199350" y="107156"/>
-                </a:lnTo>
-                <a:lnTo>
-                  <a:pt x="193158" y="99086"/>
+                  <a:pt x="233796" y="68191"/>
+                </a:lnTo>
+                <a:lnTo>
+                  <a:pt x="233796" y="126640"/>
+                </a:lnTo>
+                <a:lnTo>
+                  <a:pt x="204571" y="126640"/>
+                </a:lnTo>
+                <a:lnTo>
+                  <a:pt x="203244" y="116554"/>
+                </a:lnTo>
+                <a:lnTo>
+                  <a:pt x="199351" y="107157"/>
+                </a:lnTo>
+                <a:lnTo>
+                  <a:pt x="193158" y="99087"/>
                 </a:lnTo>
                 <a:lnTo>
                   <a:pt x="185088" y="92894"/>
                 </a:lnTo>
                 <a:lnTo>
-                  <a:pt x="175690" y="89001"/>
-                </a:lnTo>
-                <a:lnTo>
-                  <a:pt x="165605" y="87673"/>
+                  <a:pt x="175691" y="89001"/>
+                </a:lnTo>
+                <a:lnTo>
+                  <a:pt x="165605" y="87674"/>
                 </a:lnTo>
                 <a:lnTo>
                   <a:pt x="155520" y="89001"/>
@@ -3977,87 +3925,74 @@
                   <a:pt x="146122" y="92894"/>
                 </a:lnTo>
                 <a:lnTo>
-                  <a:pt x="138052" y="99086"/>
-                </a:lnTo>
-                <a:lnTo>
-                  <a:pt x="131859" y="107156"/>
+                  <a:pt x="138052" y="99087"/>
+                </a:lnTo>
+                <a:lnTo>
+                  <a:pt x="131860" y="107157"/>
                 </a:lnTo>
                 <a:lnTo>
                   <a:pt x="127967" y="116554"/>
                 </a:lnTo>
                 <a:lnTo>
-                  <a:pt x="126639" y="126639"/>
-                </a:lnTo>
-                <a:lnTo>
-                  <a:pt x="107156" y="126639"/>
-                </a:lnTo>
-                <a:lnTo>
-                  <a:pt x="105828" y="116554"/>
-                </a:lnTo>
-                <a:lnTo>
-                  <a:pt x="101936" y="107156"/>
-                </a:lnTo>
-                <a:lnTo>
-                  <a:pt x="95743" y="99086"/>
-                </a:lnTo>
-                <a:lnTo>
-                  <a:pt x="87673" y="92894"/>
-                </a:lnTo>
-                <a:lnTo>
-                  <a:pt x="78275" y="89001"/>
-                </a:lnTo>
-                <a:lnTo>
-                  <a:pt x="68190" y="87673"/>
-                </a:lnTo>
-                <a:lnTo>
-                  <a:pt x="58105" y="89001"/>
-                </a:lnTo>
-                <a:lnTo>
-                  <a:pt x="48707" y="92894"/>
-                </a:lnTo>
-                <a:lnTo>
-                  <a:pt x="40637" y="99086"/>
-                </a:lnTo>
-                <a:lnTo>
-                  <a:pt x="34445" y="107156"/>
+                  <a:pt x="126640" y="126640"/>
+                </a:lnTo>
+                <a:lnTo>
+                  <a:pt x="107157" y="126640"/>
+                </a:lnTo>
+                <a:lnTo>
+                  <a:pt x="105829" y="116554"/>
+                </a:lnTo>
+                <a:lnTo>
+                  <a:pt x="101936" y="107157"/>
+                </a:lnTo>
+                <a:lnTo>
+                  <a:pt x="95744" y="99087"/>
+                </a:lnTo>
+                <a:lnTo>
+                  <a:pt x="87674" y="92894"/>
+                </a:lnTo>
+                <a:lnTo>
+                  <a:pt x="78276" y="89001"/>
+                </a:lnTo>
+                <a:lnTo>
+                  <a:pt x="68191" y="87674"/>
+                </a:lnTo>
+                <a:lnTo>
+                  <a:pt x="58106" y="89001"/>
+                </a:lnTo>
+                <a:lnTo>
+                  <a:pt x="48708" y="92894"/>
+                </a:lnTo>
+                <a:lnTo>
+                  <a:pt x="40638" y="99087"/>
+                </a:lnTo>
+                <a:lnTo>
+                  <a:pt x="34445" y="107157"/>
                 </a:lnTo>
                 <a:lnTo>
                   <a:pt x="30552" y="116554"/>
                 </a:lnTo>
                 <a:lnTo>
-                  <a:pt x="29224" y="126639"/>
-                </a:lnTo>
-                <a:lnTo>
-                  <a:pt x="0" y="126639"/>
+                  <a:pt x="29225" y="126640"/>
+                </a:lnTo>
+                <a:lnTo>
+                  <a:pt x="0" y="126640"/>
                 </a:lnTo>
                 <a:close/>
               </a:path>
             </a:pathLst>
           </a:custGeom>
           <a:noFill/>
-          <a:ln w="19482">
+          <a:ln w="19482" cap="rnd">
             <a:solidFill>
               <a:srgbClr val="BC1227"/>
             </a:solidFill>
+            <a:round/>
           </a:ln>
           <a:effectLst/>
         </p:spPr>
-        <p:style>
-          <a:lnRef idx="1">
-            <a:schemeClr val="accent1"/>
-          </a:lnRef>
-          <a:fillRef idx="3">
-            <a:schemeClr val="accent1"/>
-          </a:fillRef>
-          <a:effectRef idx="2">
-            <a:schemeClr val="accent1"/>
-          </a:effectRef>
-          <a:fontRef idx="minor">
-            <a:schemeClr val="lt1"/>
-          </a:fontRef>
-        </p:style>
-        <p:txBody>
-          <a:bodyPr rtlCol="0" anchor="ctr"/>
+        <p:txBody>
+          <a:bodyPr rtlCol="0" anchor="ctr" wrap="square"/>
           <a:lstStyle/>
           <a:p>
             <a:pPr algn="ctr"/>
@@ -4073,7 +4008,7 @@
         <p:spPr>
           <a:xfrm>
             <a:off x="5835121" y="2519795"/>
-            <a:ext cx="155863" cy="38966"/>
+            <a:ext cx="155864" cy="38966"/>
           </a:xfrm>
           <a:custGeom>
             <a:avLst/>
@@ -4082,46 +4017,33 @@
             <a:cxnLst/>
             <a:rect l="l" t="t" r="r" b="b"/>
             <a:pathLst>
-              <a:path w="155863" h="38966">
+              <a:path w="155864" h="38966">
                 <a:moveTo>
                   <a:pt x="0" y="38966"/>
                 </a:moveTo>
                 <a:lnTo>
-                  <a:pt x="29224" y="0"/>
+                  <a:pt x="29225" y="0"/>
                 </a:lnTo>
                 <a:lnTo>
                   <a:pt x="126639" y="0"/>
                 </a:lnTo>
                 <a:lnTo>
-                  <a:pt x="155863" y="38966"/>
+                  <a:pt x="155864" y="38966"/>
                 </a:lnTo>
               </a:path>
             </a:pathLst>
           </a:custGeom>
           <a:noFill/>
-          <a:ln w="19482">
+          <a:ln w="19482" cap="rnd">
             <a:solidFill>
               <a:srgbClr val="BC1227"/>
             </a:solidFill>
+            <a:round/>
           </a:ln>
           <a:effectLst/>
         </p:spPr>
-        <p:style>
-          <a:lnRef idx="1">
-            <a:schemeClr val="accent1"/>
-          </a:lnRef>
-          <a:fillRef idx="3">
-            <a:schemeClr val="accent1"/>
-          </a:fillRef>
-          <a:effectRef idx="2">
-            <a:schemeClr val="accent1"/>
-          </a:effectRef>
-          <a:fontRef idx="minor">
-            <a:schemeClr val="lt1"/>
-          </a:fontRef>
-        </p:style>
-        <p:txBody>
-          <a:bodyPr rtlCol="0" anchor="ctr"/>
+        <p:txBody>
+          <a:bodyPr rtlCol="0" anchor="ctr" wrap="square"/>
           <a:lstStyle/>
           <a:p>
             <a:pPr algn="ctr"/>
@@ -4143,29 +4065,16 @@
             <a:avLst/>
           </a:prstGeom>
           <a:noFill/>
-          <a:ln w="19482">
+          <a:ln w="19482" cap="rnd">
             <a:solidFill>
               <a:srgbClr val="BC1227"/>
             </a:solidFill>
+            <a:round/>
           </a:ln>
           <a:effectLst/>
         </p:spPr>
-        <p:style>
-          <a:lnRef idx="1">
-            <a:schemeClr val="accent1"/>
-          </a:lnRef>
-          <a:fillRef idx="3">
-            <a:schemeClr val="accent1"/>
-          </a:fillRef>
-          <a:effectRef idx="2">
-            <a:schemeClr val="accent1"/>
-          </a:effectRef>
-          <a:fontRef idx="minor">
-            <a:schemeClr val="lt1"/>
-          </a:fontRef>
-        </p:style>
-        <p:txBody>
-          <a:bodyPr rtlCol="0" anchor="ctr"/>
+        <p:txBody>
+          <a:bodyPr rtlCol="0" anchor="ctr" wrap="square"/>
           <a:lstStyle/>
           <a:p>
             <a:pPr algn="ctr"/>
@@ -4187,29 +4096,16 @@
             <a:avLst/>
           </a:prstGeom>
           <a:noFill/>
-          <a:ln w="19482">
+          <a:ln w="19482" cap="rnd">
             <a:solidFill>
               <a:srgbClr val="BC1227"/>
             </a:solidFill>
+            <a:round/>
           </a:ln>
           <a:effectLst/>
         </p:spPr>
-        <p:style>
-          <a:lnRef idx="1">
-            <a:schemeClr val="accent1"/>
-          </a:lnRef>
-          <a:fillRef idx="3">
-            <a:schemeClr val="accent1"/>
-          </a:fillRef>
-          <a:effectRef idx="2">
-            <a:schemeClr val="accent1"/>
-          </a:effectRef>
-          <a:fontRef idx="minor">
-            <a:schemeClr val="lt1"/>
-          </a:fontRef>
-        </p:style>
-        <p:txBody>
-          <a:bodyPr rtlCol="0" anchor="ctr"/>
+        <p:txBody>
+          <a:bodyPr rtlCol="0" anchor="ctr" wrap="square"/>
           <a:lstStyle/>
           <a:p>
             <a:pPr algn="ctr"/>
@@ -4326,8 +4222,8 @@
         </p:nvSpPr>
         <p:spPr>
           <a:xfrm>
-            <a:off x="8974769" y="2490571"/>
-            <a:ext cx="214313" cy="68190"/>
+            <a:off x="8974770" y="2490571"/>
+            <a:ext cx="214312" cy="68190"/>
           </a:xfrm>
           <a:custGeom>
             <a:avLst/>
@@ -4336,43 +4232,30 @@
             <a:cxnLst/>
             <a:rect l="l" t="t" r="r" b="b"/>
             <a:pathLst>
-              <a:path w="214313" h="68190">
+              <a:path w="214312" h="68190">
                 <a:moveTo>
                   <a:pt x="0" y="68190"/>
                 </a:moveTo>
                 <a:lnTo>
-                  <a:pt x="107157" y="0"/>
-                </a:lnTo>
-                <a:lnTo>
-                  <a:pt x="214313" y="68190"/>
+                  <a:pt x="107156" y="0"/>
+                </a:lnTo>
+                <a:lnTo>
+                  <a:pt x="214312" y="68190"/>
                 </a:lnTo>
               </a:path>
             </a:pathLst>
           </a:custGeom>
           <a:noFill/>
-          <a:ln w="19482">
+          <a:ln w="19482" cap="rnd">
             <a:solidFill>
               <a:srgbClr val="BC1227"/>
             </a:solidFill>
+            <a:round/>
           </a:ln>
           <a:effectLst/>
         </p:spPr>
-        <p:style>
-          <a:lnRef idx="1">
-            <a:schemeClr val="accent1"/>
-          </a:lnRef>
-          <a:fillRef idx="3">
-            <a:schemeClr val="accent1"/>
-          </a:fillRef>
-          <a:effectRef idx="2">
-            <a:schemeClr val="accent1"/>
-          </a:effectRef>
-          <a:fontRef idx="minor">
-            <a:schemeClr val="lt1"/>
-          </a:fontRef>
-        </p:style>
-        <p:txBody>
-          <a:bodyPr rtlCol="0" anchor="ctr"/>
+        <p:txBody>
+          <a:bodyPr rtlCol="0" anchor="ctr" wrap="square"/>
           <a:lstStyle/>
           <a:p>
             <a:pPr algn="ctr"/>
@@ -4393,7 +4276,7 @@
           <a:prstGeom prst="line">
             <a:avLst/>
           </a:prstGeom>
-          <a:ln w="19482">
+          <a:ln w="19482" cap="rnd">
             <a:solidFill>
               <a:srgbClr val="BC1227"/>
             </a:solidFill>
@@ -4428,7 +4311,7 @@
           <a:prstGeom prst="line">
             <a:avLst/>
           </a:prstGeom>
-          <a:ln w="19482">
+          <a:ln w="19482" cap="rnd">
             <a:solidFill>
               <a:srgbClr val="BC1227"/>
             </a:solidFill>
@@ -4463,7 +4346,7 @@
           <a:prstGeom prst="line">
             <a:avLst/>
           </a:prstGeom>
-          <a:ln w="19482">
+          <a:ln w="19482" cap="rnd">
             <a:solidFill>
               <a:srgbClr val="BC1227"/>
             </a:solidFill>
@@ -4498,7 +4381,7 @@
           <a:prstGeom prst="line">
             <a:avLst/>
           </a:prstGeom>
-          <a:ln w="19482">
+          <a:ln w="19482" cap="rnd">
             <a:solidFill>
               <a:srgbClr val="BC1227"/>
             </a:solidFill>
@@ -4533,7 +4416,7 @@
           <a:prstGeom prst="line">
             <a:avLst/>
           </a:prstGeom>
-          <a:ln w="19482">
+          <a:ln w="19482" cap="rnd">
             <a:solidFill>
               <a:srgbClr val="BC1227"/>
             </a:solidFill>
@@ -4870,8 +4753,8 @@
         </p:nvSpPr>
         <p:spPr>
           <a:xfrm>
-            <a:off x="758331" y="4233970"/>
-            <a:ext cx="250031" cy="79556"/>
+            <a:off x="758332" y="4233971"/>
+            <a:ext cx="250031" cy="79555"/>
           </a:xfrm>
           <a:custGeom>
             <a:avLst/>
@@ -4880,43 +4763,30 @@
             <a:cxnLst/>
             <a:rect l="l" t="t" r="r" b="b"/>
             <a:pathLst>
-              <a:path w="250031" h="79556">
+              <a:path w="250031" h="79555">
                 <a:moveTo>
-                  <a:pt x="0" y="79556"/>
+                  <a:pt x="0" y="79555"/>
                 </a:moveTo>
                 <a:lnTo>
-                  <a:pt x="125016" y="0"/>
-                </a:lnTo>
-                <a:lnTo>
-                  <a:pt x="250031" y="79556"/>
+                  <a:pt x="125015" y="0"/>
+                </a:lnTo>
+                <a:lnTo>
+                  <a:pt x="250031" y="79555"/>
                 </a:lnTo>
               </a:path>
             </a:pathLst>
           </a:custGeom>
           <a:noFill/>
-          <a:ln w="22730">
+          <a:ln w="22730" cap="rnd">
             <a:solidFill>
               <a:srgbClr val="B6162D"/>
             </a:solidFill>
+            <a:round/>
           </a:ln>
           <a:effectLst/>
         </p:spPr>
-        <p:style>
-          <a:lnRef idx="1">
-            <a:schemeClr val="accent1"/>
-          </a:lnRef>
-          <a:fillRef idx="3">
-            <a:schemeClr val="accent1"/>
-          </a:fillRef>
-          <a:effectRef idx="2">
-            <a:schemeClr val="accent1"/>
-          </a:effectRef>
-          <a:fontRef idx="minor">
-            <a:schemeClr val="lt1"/>
-          </a:fontRef>
-        </p:style>
-        <p:txBody>
-          <a:bodyPr rtlCol="0" anchor="ctr"/>
+        <p:txBody>
+          <a:bodyPr rtlCol="0" anchor="ctr" wrap="square"/>
           <a:lstStyle/>
           <a:p>
             <a:pPr algn="ctr"/>
@@ -4937,7 +4807,7 @@
           <a:prstGeom prst="line">
             <a:avLst/>
           </a:prstGeom>
-          <a:ln w="22730">
+          <a:ln w="22730" cap="rnd">
             <a:solidFill>
               <a:srgbClr val="B6162D"/>
             </a:solidFill>
@@ -4972,7 +4842,7 @@
           <a:prstGeom prst="line">
             <a:avLst/>
           </a:prstGeom>
-          <a:ln w="22730">
+          <a:ln w="22730" cap="rnd">
             <a:solidFill>
               <a:srgbClr val="B6162D"/>
             </a:solidFill>
@@ -5007,7 +4877,7 @@
           <a:prstGeom prst="line">
             <a:avLst/>
           </a:prstGeom>
-          <a:ln w="22730">
+          <a:ln w="22730" cap="rnd">
             <a:solidFill>
               <a:srgbClr val="B6162D"/>
             </a:solidFill>
@@ -5042,7 +4912,7 @@
           <a:prstGeom prst="line">
             <a:avLst/>
           </a:prstGeom>
-          <a:ln w="22730">
+          <a:ln w="22730" cap="rnd">
             <a:solidFill>
               <a:srgbClr val="B6162D"/>
             </a:solidFill>
@@ -5077,7 +4947,7 @@
           <a:prstGeom prst="line">
             <a:avLst/>
           </a:prstGeom>
-          <a:ln w="22730">
+          <a:ln w="22730" cap="rnd">
             <a:solidFill>
               <a:srgbClr val="B6162D"/>
             </a:solidFill>
@@ -5283,29 +5153,16 @@
             <a:avLst/>
           </a:prstGeom>
           <a:noFill/>
-          <a:ln w="22730">
+          <a:ln w="22730" cap="rnd">
             <a:solidFill>
               <a:srgbClr val="111111"/>
             </a:solidFill>
+            <a:round/>
           </a:ln>
           <a:effectLst/>
         </p:spPr>
-        <p:style>
-          <a:lnRef idx="1">
-            <a:schemeClr val="accent1"/>
-          </a:lnRef>
-          <a:fillRef idx="3">
-            <a:schemeClr val="accent1"/>
-          </a:fillRef>
-          <a:effectRef idx="2">
-            <a:schemeClr val="accent1"/>
-          </a:effectRef>
-          <a:fontRef idx="minor">
-            <a:schemeClr val="lt1"/>
-          </a:fontRef>
-        </p:style>
-        <p:txBody>
-          <a:bodyPr rtlCol="0" anchor="ctr"/>
+        <p:txBody>
+          <a:bodyPr rtlCol="0" anchor="ctr" wrap="square"/>
           <a:lstStyle/>
           <a:p>
             <a:pPr algn="ctr"/>
@@ -5327,29 +5184,16 @@
             <a:avLst/>
           </a:prstGeom>
           <a:noFill/>
-          <a:ln w="22730">
+          <a:ln w="22730" cap="rnd">
             <a:solidFill>
               <a:srgbClr val="111111"/>
             </a:solidFill>
+            <a:round/>
           </a:ln>
           <a:effectLst/>
         </p:spPr>
-        <p:style>
-          <a:lnRef idx="1">
-            <a:schemeClr val="accent1"/>
-          </a:lnRef>
-          <a:fillRef idx="3">
-            <a:schemeClr val="accent1"/>
-          </a:fillRef>
-          <a:effectRef idx="2">
-            <a:schemeClr val="accent1"/>
-          </a:effectRef>
-          <a:fontRef idx="minor">
-            <a:schemeClr val="lt1"/>
-          </a:fontRef>
-        </p:style>
-        <p:txBody>
-          <a:bodyPr rtlCol="0" anchor="ctr"/>
+        <p:txBody>
+          <a:bodyPr rtlCol="0" anchor="ctr" wrap="square"/>
           <a:lstStyle/>
           <a:p>
             <a:pPr algn="ctr"/>
@@ -5370,7 +5214,7 @@
           <a:prstGeom prst="line">
             <a:avLst/>
           </a:prstGeom>
-          <a:ln w="22730">
+          <a:ln w="22730" cap="rnd">
             <a:solidFill>
               <a:srgbClr val="111111"/>
             </a:solidFill>
@@ -5405,7 +5249,7 @@
           <a:prstGeom prst="line">
             <a:avLst/>
           </a:prstGeom>
-          <a:ln w="22730">
+          <a:ln w="22730" cap="rnd">
             <a:solidFill>
               <a:srgbClr val="111111"/>
             </a:solidFill>
@@ -5440,7 +5284,7 @@
           <a:prstGeom prst="line">
             <a:avLst/>
           </a:prstGeom>
-          <a:ln w="22730">
+          <a:ln w="22730" cap="rnd">
             <a:solidFill>
               <a:srgbClr val="111111"/>
             </a:solidFill>
@@ -5475,7 +5319,7 @@
           <a:prstGeom prst="line">
             <a:avLst/>
           </a:prstGeom>
-          <a:ln w="22730">
+          <a:ln w="22730" cap="rnd">
             <a:solidFill>
               <a:srgbClr val="111111"/>
             </a:solidFill>
@@ -5510,7 +5354,7 @@
           <a:prstGeom prst="line">
             <a:avLst/>
           </a:prstGeom>
-          <a:ln w="22730">
+          <a:ln w="22730" cap="rnd">
             <a:solidFill>
               <a:srgbClr val="111111"/>
             </a:solidFill>
@@ -5545,7 +5389,7 @@
           <a:prstGeom prst="line">
             <a:avLst/>
           </a:prstGeom>
-          <a:ln w="22730">
+          <a:ln w="22730" cap="rnd">
             <a:solidFill>
               <a:srgbClr val="111111"/>
             </a:solidFill>
@@ -5580,7 +5424,7 @@
           <a:prstGeom prst="line">
             <a:avLst/>
           </a:prstGeom>
-          <a:ln w="22730">
+          <a:ln w="22730" cap="rnd">
             <a:solidFill>
               <a:srgbClr val="111111"/>
             </a:solidFill>
@@ -5615,7 +5459,7 @@
           <a:prstGeom prst="line">
             <a:avLst/>
           </a:prstGeom>
-          <a:ln w="22730">
+          <a:ln w="22730" cap="rnd">
             <a:solidFill>
               <a:srgbClr val="111111"/>
             </a:solidFill>
@@ -5814,8 +5658,8 @@
         </p:nvSpPr>
         <p:spPr>
           <a:xfrm>
-            <a:off x="5306027" y="4233970"/>
-            <a:ext cx="250031" cy="181841"/>
+            <a:off x="5306027" y="4233971"/>
+            <a:ext cx="250032" cy="181841"/>
           </a:xfrm>
           <a:custGeom>
             <a:avLst/>
@@ -5824,15 +5668,15 @@
             <a:cxnLst/>
             <a:rect l="l" t="t" r="r" b="b"/>
             <a:pathLst>
-              <a:path w="250031" h="181841">
+              <a:path w="250032" h="181841">
                 <a:moveTo>
                   <a:pt x="0" y="0"/>
                 </a:moveTo>
                 <a:lnTo>
-                  <a:pt x="250031" y="0"/>
-                </a:lnTo>
-                <a:lnTo>
-                  <a:pt x="250031" y="181841"/>
+                  <a:pt x="250032" y="0"/>
+                </a:lnTo>
+                <a:lnTo>
+                  <a:pt x="250032" y="181841"/>
                 </a:lnTo>
                 <a:lnTo>
                   <a:pt x="0" y="181841"/>
@@ -5842,29 +5686,16 @@
             </a:pathLst>
           </a:custGeom>
           <a:noFill/>
-          <a:ln w="22730">
+          <a:ln w="22730" cap="rnd">
             <a:solidFill>
               <a:srgbClr val="111111"/>
             </a:solidFill>
+            <a:round/>
           </a:ln>
           <a:effectLst/>
         </p:spPr>
-        <p:style>
-          <a:lnRef idx="1">
-            <a:schemeClr val="accent1"/>
-          </a:lnRef>
-          <a:fillRef idx="3">
-            <a:schemeClr val="accent1"/>
-          </a:fillRef>
-          <a:effectRef idx="2">
-            <a:schemeClr val="accent1"/>
-          </a:effectRef>
-          <a:fontRef idx="minor">
-            <a:schemeClr val="lt1"/>
-          </a:fontRef>
-        </p:style>
-        <p:txBody>
-          <a:bodyPr rtlCol="0" anchor="ctr"/>
+        <p:txBody>
+          <a:bodyPr rtlCol="0" anchor="ctr" wrap="square"/>
           <a:lstStyle/>
           <a:p>
             <a:pPr algn="ctr"/>
@@ -5885,7 +5716,7 @@
           <a:prstGeom prst="line">
             <a:avLst/>
           </a:prstGeom>
-          <a:ln w="22730">
+          <a:ln w="22730" cap="rnd">
             <a:solidFill>
               <a:srgbClr val="111111"/>
             </a:solidFill>
@@ -5920,7 +5751,7 @@
           <a:prstGeom prst="line">
             <a:avLst/>
           </a:prstGeom>
-          <a:ln w="22730">
+          <a:ln w="22730" cap="rnd">
             <a:solidFill>
               <a:srgbClr val="111111"/>
             </a:solidFill>
@@ -6142,29 +5973,16 @@
             <a:avLst/>
           </a:prstGeom>
           <a:noFill/>
-          <a:ln w="22730">
+          <a:ln w="22730" cap="rnd">
             <a:solidFill>
               <a:srgbClr val="111111"/>
             </a:solidFill>
+            <a:round/>
           </a:ln>
           <a:effectLst/>
         </p:spPr>
-        <p:style>
-          <a:lnRef idx="1">
-            <a:schemeClr val="accent1"/>
-          </a:lnRef>
-          <a:fillRef idx="3">
-            <a:schemeClr val="accent1"/>
-          </a:fillRef>
-          <a:effectRef idx="2">
-            <a:schemeClr val="accent1"/>
-          </a:effectRef>
-          <a:fontRef idx="minor">
-            <a:schemeClr val="lt1"/>
-          </a:fontRef>
-        </p:style>
-        <p:txBody>
-          <a:bodyPr rtlCol="0" anchor="ctr"/>
+        <p:txBody>
+          <a:bodyPr rtlCol="0" anchor="ctr" wrap="square"/>
           <a:lstStyle/>
           <a:p>
             <a:pPr algn="ctr"/>
@@ -6186,29 +6004,16 @@
             <a:avLst/>
           </a:prstGeom>
           <a:noFill/>
-          <a:ln w="22730">
+          <a:ln w="22730" cap="rnd">
             <a:solidFill>
               <a:srgbClr val="111111"/>
             </a:solidFill>
+            <a:round/>
           </a:ln>
           <a:effectLst/>
         </p:spPr>
-        <p:style>
-          <a:lnRef idx="1">
-            <a:schemeClr val="accent1"/>
-          </a:lnRef>
-          <a:fillRef idx="3">
-            <a:schemeClr val="accent1"/>
-          </a:fillRef>
-          <a:effectRef idx="2">
-            <a:schemeClr val="accent1"/>
-          </a:effectRef>
-          <a:fontRef idx="minor">
-            <a:schemeClr val="lt1"/>
-          </a:fontRef>
-        </p:style>
-        <p:txBody>
-          <a:bodyPr rtlCol="0" anchor="ctr"/>
+        <p:txBody>
+          <a:bodyPr rtlCol="0" anchor="ctr" wrap="square"/>
           <a:lstStyle/>
           <a:p>
             <a:pPr algn="ctr"/>
@@ -6224,7 +6029,7 @@
         <p:spPr>
           <a:xfrm>
             <a:off x="7568510" y="4358986"/>
-            <a:ext cx="181841" cy="102285"/>
+            <a:ext cx="181841" cy="102286"/>
           </a:xfrm>
           <a:custGeom>
             <a:avLst/>
@@ -6233,121 +6038,108 @@
             <a:cxnLst/>
             <a:rect l="l" t="t" r="r" b="b"/>
             <a:pathLst>
-              <a:path w="181841" h="102285">
+              <a:path w="181841" h="102286">
                 <a:moveTo>
-                  <a:pt x="0" y="102285"/>
+                  <a:pt x="0" y="102286"/>
                 </a:moveTo>
                 <a:lnTo>
-                  <a:pt x="1729" y="88195"/>
-                </a:lnTo>
-                <a:lnTo>
-                  <a:pt x="4440" y="75148"/>
-                </a:lnTo>
-                <a:lnTo>
-                  <a:pt x="8070" y="63146"/>
-                </a:lnTo>
-                <a:lnTo>
-                  <a:pt x="12558" y="52186"/>
-                </a:lnTo>
-                <a:lnTo>
-                  <a:pt x="17840" y="42271"/>
-                </a:lnTo>
-                <a:lnTo>
-                  <a:pt x="23856" y="33399"/>
-                </a:lnTo>
-                <a:lnTo>
-                  <a:pt x="30543" y="25571"/>
-                </a:lnTo>
-                <a:lnTo>
-                  <a:pt x="37839" y="18787"/>
-                </a:lnTo>
-                <a:lnTo>
-                  <a:pt x="45682" y="13046"/>
+                  <a:pt x="1729" y="88196"/>
+                </a:lnTo>
+                <a:lnTo>
+                  <a:pt x="4440" y="75149"/>
+                </a:lnTo>
+                <a:lnTo>
+                  <a:pt x="8071" y="63146"/>
+                </a:lnTo>
+                <a:lnTo>
+                  <a:pt x="12558" y="52187"/>
+                </a:lnTo>
+                <a:lnTo>
+                  <a:pt x="17841" y="42271"/>
+                </a:lnTo>
+                <a:lnTo>
+                  <a:pt x="23857" y="33400"/>
+                </a:lnTo>
+                <a:lnTo>
+                  <a:pt x="30544" y="25572"/>
+                </a:lnTo>
+                <a:lnTo>
+                  <a:pt x="37840" y="18787"/>
+                </a:lnTo>
+                <a:lnTo>
+                  <a:pt x="45682" y="13047"/>
                 </a:lnTo>
                 <a:lnTo>
                   <a:pt x="54009" y="8350"/>
                 </a:lnTo>
                 <a:lnTo>
-                  <a:pt x="62758" y="4697"/>
-                </a:lnTo>
-                <a:lnTo>
-                  <a:pt x="71868" y="2087"/>
-                </a:lnTo>
-                <a:lnTo>
-                  <a:pt x="81276" y="522"/>
-                </a:lnTo>
-                <a:lnTo>
-                  <a:pt x="90920" y="0"/>
-                </a:lnTo>
-                <a:lnTo>
-                  <a:pt x="100564" y="522"/>
-                </a:lnTo>
-                <a:lnTo>
-                  <a:pt x="109972" y="2087"/>
-                </a:lnTo>
-                <a:lnTo>
-                  <a:pt x="119082" y="4697"/>
+                  <a:pt x="62759" y="4697"/>
+                </a:lnTo>
+                <a:lnTo>
+                  <a:pt x="71868" y="2088"/>
+                </a:lnTo>
+                <a:lnTo>
+                  <a:pt x="81277" y="522"/>
+                </a:lnTo>
+                <a:lnTo>
+                  <a:pt x="90921" y="0"/>
+                </a:lnTo>
+                <a:lnTo>
+                  <a:pt x="100565" y="522"/>
+                </a:lnTo>
+                <a:lnTo>
+                  <a:pt x="109973" y="2088"/>
+                </a:lnTo>
+                <a:lnTo>
+                  <a:pt x="119083" y="4697"/>
                 </a:lnTo>
                 <a:lnTo>
                   <a:pt x="127832" y="8350"/>
                 </a:lnTo>
                 <a:lnTo>
-                  <a:pt x="136159" y="13046"/>
-                </a:lnTo>
-                <a:lnTo>
-                  <a:pt x="144001" y="18787"/>
-                </a:lnTo>
-                <a:lnTo>
-                  <a:pt x="151297" y="25571"/>
-                </a:lnTo>
-                <a:lnTo>
-                  <a:pt x="157984" y="33399"/>
+                  <a:pt x="136159" y="13047"/>
+                </a:lnTo>
+                <a:lnTo>
+                  <a:pt x="144002" y="18787"/>
+                </a:lnTo>
+                <a:lnTo>
+                  <a:pt x="151298" y="25572"/>
+                </a:lnTo>
+                <a:lnTo>
+                  <a:pt x="157984" y="33400"/>
                 </a:lnTo>
                 <a:lnTo>
                   <a:pt x="164000" y="42271"/>
                 </a:lnTo>
                 <a:lnTo>
-                  <a:pt x="169283" y="52186"/>
-                </a:lnTo>
-                <a:lnTo>
-                  <a:pt x="173770" y="63146"/>
-                </a:lnTo>
-                <a:lnTo>
-                  <a:pt x="177401" y="75148"/>
-                </a:lnTo>
-                <a:lnTo>
-                  <a:pt x="180111" y="88195"/>
-                </a:lnTo>
-                <a:lnTo>
-                  <a:pt x="181841" y="102285"/>
+                  <a:pt x="169283" y="52187"/>
+                </a:lnTo>
+                <a:lnTo>
+                  <a:pt x="173771" y="63146"/>
+                </a:lnTo>
+                <a:lnTo>
+                  <a:pt x="177401" y="75149"/>
+                </a:lnTo>
+                <a:lnTo>
+                  <a:pt x="180112" y="88196"/>
+                </a:lnTo>
+                <a:lnTo>
+                  <a:pt x="181841" y="102286"/>
                 </a:lnTo>
               </a:path>
             </a:pathLst>
           </a:custGeom>
           <a:noFill/>
-          <a:ln w="22730">
+          <a:ln w="22730" cap="rnd">
             <a:solidFill>
               <a:srgbClr val="111111"/>
             </a:solidFill>
+            <a:round/>
           </a:ln>
           <a:effectLst/>
         </p:spPr>
-        <p:style>
-          <a:lnRef idx="1">
-            <a:schemeClr val="accent1"/>
-          </a:lnRef>
-          <a:fillRef idx="3">
-            <a:schemeClr val="accent1"/>
-          </a:fillRef>
-          <a:effectRef idx="2">
-            <a:schemeClr val="accent1"/>
-          </a:effectRef>
-          <a:fontRef idx="minor">
-            <a:schemeClr val="lt1"/>
-          </a:fontRef>
-        </p:style>
-        <p:txBody>
-          <a:bodyPr rtlCol="0" anchor="ctr"/>
+        <p:txBody>
+          <a:bodyPr rtlCol="0" anchor="ctr" wrap="square"/>
           <a:lstStyle/>
           <a:p>
             <a:pPr algn="ctr"/>
@@ -6362,7 +6154,7 @@
         </p:nvSpPr>
         <p:spPr>
           <a:xfrm>
-            <a:off x="7670795" y="4376033"/>
+            <a:off x="7670796" y="4376034"/>
             <a:ext cx="159111" cy="85238"/>
           </a:xfrm>
           <a:custGeom>
@@ -6377,13 +6169,13 @@
                   <a:pt x="0" y="85238"/>
                 </a:moveTo>
                 <a:lnTo>
-                  <a:pt x="1645" y="73496"/>
-                </a:lnTo>
-                <a:lnTo>
-                  <a:pt x="4109" y="62624"/>
-                </a:lnTo>
-                <a:lnTo>
-                  <a:pt x="7344" y="52622"/>
+                  <a:pt x="1644" y="73496"/>
+                </a:lnTo>
+                <a:lnTo>
+                  <a:pt x="4108" y="62624"/>
+                </a:lnTo>
+                <a:lnTo>
+                  <a:pt x="7343" y="52621"/>
                 </a:lnTo>
                 <a:lnTo>
                   <a:pt x="11299" y="43489"/>
@@ -6395,67 +6187,67 @@
                   <a:pt x="21173" y="27833"/>
                 </a:lnTo>
                 <a:lnTo>
-                  <a:pt x="26992" y="21310"/>
+                  <a:pt x="26992" y="21309"/>
                 </a:lnTo>
                 <a:lnTo>
                   <a:pt x="33333" y="15656"/>
                 </a:lnTo>
                 <a:lnTo>
-                  <a:pt x="40147" y="10873"/>
-                </a:lnTo>
-                <a:lnTo>
-                  <a:pt x="47382" y="6959"/>
-                </a:lnTo>
-                <a:lnTo>
-                  <a:pt x="54991" y="3914"/>
-                </a:lnTo>
-                <a:lnTo>
-                  <a:pt x="62922" y="1740"/>
+                  <a:pt x="40146" y="10872"/>
+                </a:lnTo>
+                <a:lnTo>
+                  <a:pt x="47382" y="6958"/>
+                </a:lnTo>
+                <a:lnTo>
+                  <a:pt x="54990" y="3914"/>
+                </a:lnTo>
+                <a:lnTo>
+                  <a:pt x="62922" y="1739"/>
                 </a:lnTo>
                 <a:lnTo>
                   <a:pt x="71127" y="435"/>
                 </a:lnTo>
                 <a:lnTo>
-                  <a:pt x="79556" y="0"/>
+                  <a:pt x="79555" y="0"/>
                 </a:lnTo>
                 <a:lnTo>
                   <a:pt x="87984" y="435"/>
                 </a:lnTo>
                 <a:lnTo>
-                  <a:pt x="96189" y="1740"/>
-                </a:lnTo>
-                <a:lnTo>
-                  <a:pt x="104121" y="3914"/>
-                </a:lnTo>
-                <a:lnTo>
-                  <a:pt x="111729" y="6959"/>
-                </a:lnTo>
-                <a:lnTo>
-                  <a:pt x="118965" y="10873"/>
-                </a:lnTo>
-                <a:lnTo>
-                  <a:pt x="125778" y="15656"/>
-                </a:lnTo>
-                <a:lnTo>
-                  <a:pt x="132119" y="21310"/>
+                  <a:pt x="96189" y="1739"/>
+                </a:lnTo>
+                <a:lnTo>
+                  <a:pt x="104120" y="3914"/>
+                </a:lnTo>
+                <a:lnTo>
+                  <a:pt x="111729" y="6958"/>
+                </a:lnTo>
+                <a:lnTo>
+                  <a:pt x="118964" y="10872"/>
+                </a:lnTo>
+                <a:lnTo>
+                  <a:pt x="125777" y="15656"/>
+                </a:lnTo>
+                <a:lnTo>
+                  <a:pt x="132119" y="21309"/>
                 </a:lnTo>
                 <a:lnTo>
                   <a:pt x="137938" y="27833"/>
                 </a:lnTo>
                 <a:lnTo>
-                  <a:pt x="143186" y="35226"/>
+                  <a:pt x="143185" y="35226"/>
                 </a:lnTo>
                 <a:lnTo>
                   <a:pt x="147812" y="43489"/>
                 </a:lnTo>
                 <a:lnTo>
-                  <a:pt x="151768" y="52622"/>
+                  <a:pt x="151767" y="52621"/>
                 </a:lnTo>
                 <a:lnTo>
                   <a:pt x="155002" y="62624"/>
                 </a:lnTo>
                 <a:lnTo>
-                  <a:pt x="157467" y="73496"/>
+                  <a:pt x="157466" y="73496"/>
                 </a:lnTo>
                 <a:lnTo>
                   <a:pt x="159111" y="85238"/>
@@ -6464,29 +6256,16 @@
             </a:pathLst>
           </a:custGeom>
           <a:noFill/>
-          <a:ln w="22730">
+          <a:ln w="22730" cap="rnd">
             <a:solidFill>
               <a:srgbClr val="111111"/>
             </a:solidFill>
+            <a:round/>
           </a:ln>
           <a:effectLst/>
         </p:spPr>
-        <p:style>
-          <a:lnRef idx="1">
-            <a:schemeClr val="accent1"/>
-          </a:lnRef>
-          <a:fillRef idx="3">
-            <a:schemeClr val="accent1"/>
-          </a:fillRef>
-          <a:effectRef idx="2">
-            <a:schemeClr val="accent1"/>
-          </a:effectRef>
-          <a:fontRef idx="minor">
-            <a:schemeClr val="lt1"/>
-          </a:fontRef>
-        </p:style>
-        <p:txBody>
-          <a:bodyPr rtlCol="0" anchor="ctr"/>
+        <p:txBody>
+          <a:bodyPr rtlCol="0" anchor="ctr" wrap="square"/>
           <a:lstStyle/>
           <a:p>
             <a:pPr algn="ctr"/>
@@ -6643,29 +6422,16 @@
             <a:avLst/>
           </a:prstGeom>
           <a:noFill/>
-          <a:ln w="22730">
+          <a:ln w="22730" cap="rnd">
             <a:solidFill>
               <a:srgbClr val="111111"/>
             </a:solidFill>
+            <a:round/>
           </a:ln>
           <a:effectLst/>
         </p:spPr>
-        <p:style>
-          <a:lnRef idx="1">
-            <a:schemeClr val="accent1"/>
-          </a:lnRef>
-          <a:fillRef idx="3">
-            <a:schemeClr val="accent1"/>
-          </a:fillRef>
-          <a:effectRef idx="2">
-            <a:schemeClr val="accent1"/>
-          </a:effectRef>
-          <a:fontRef idx="minor">
-            <a:schemeClr val="lt1"/>
-          </a:fontRef>
-        </p:style>
-        <p:txBody>
-          <a:bodyPr rtlCol="0" anchor="ctr"/>
+        <p:txBody>
+          <a:bodyPr rtlCol="0" anchor="ctr" wrap="square"/>
           <a:lstStyle/>
           <a:p>
             <a:pPr algn="ctr"/>
@@ -6687,29 +6453,16 @@
             <a:avLst/>
           </a:prstGeom>
           <a:noFill/>
-          <a:ln w="22730">
+          <a:ln w="22730" cap="rnd">
             <a:solidFill>
               <a:srgbClr val="111111"/>
             </a:solidFill>
+            <a:round/>
           </a:ln>
           <a:effectLst/>
         </p:spPr>
-        <p:style>
-          <a:lnRef idx="1">
-            <a:schemeClr val="accent1"/>
-          </a:lnRef>
-          <a:fillRef idx="3">
-            <a:schemeClr val="accent1"/>
-          </a:fillRef>
-          <a:effectRef idx="2">
-            <a:schemeClr val="accent1"/>
-          </a:effectRef>
-          <a:fontRef idx="minor">
-            <a:schemeClr val="lt1"/>
-          </a:fontRef>
-        </p:style>
-        <p:txBody>
-          <a:bodyPr rtlCol="0" anchor="ctr"/>
+        <p:txBody>
+          <a:bodyPr rtlCol="0" anchor="ctr" wrap="square"/>
           <a:lstStyle/>
           <a:p>
             <a:pPr algn="ctr"/>
@@ -6731,29 +6484,16 @@
             <a:avLst/>
           </a:prstGeom>
           <a:noFill/>
-          <a:ln w="22730">
+          <a:ln w="22730" cap="rnd">
             <a:solidFill>
               <a:srgbClr val="111111"/>
             </a:solidFill>
+            <a:round/>
           </a:ln>
           <a:effectLst/>
         </p:spPr>
-        <p:style>
-          <a:lnRef idx="1">
-            <a:schemeClr val="accent1"/>
-          </a:lnRef>
-          <a:fillRef idx="3">
-            <a:schemeClr val="accent1"/>
-          </a:fillRef>
-          <a:effectRef idx="2">
-            <a:schemeClr val="accent1"/>
-          </a:effectRef>
-          <a:fontRef idx="minor">
-            <a:schemeClr val="lt1"/>
-          </a:fontRef>
-        </p:style>
-        <p:txBody>
-          <a:bodyPr rtlCol="0" anchor="ctr"/>
+        <p:txBody>
+          <a:bodyPr rtlCol="0" anchor="ctr" wrap="square"/>
           <a:lstStyle/>
           <a:p>
             <a:pPr algn="ctr"/>
@@ -6774,7 +6514,7 @@
           <a:prstGeom prst="line">
             <a:avLst/>
           </a:prstGeom>
-          <a:ln w="22730">
+          <a:ln w="22730" cap="rnd">
             <a:solidFill>
               <a:srgbClr val="111111"/>
             </a:solidFill>
@@ -6809,7 +6549,7 @@
           <a:prstGeom prst="line">
             <a:avLst/>
           </a:prstGeom>
-          <a:ln w="22730">
+          <a:ln w="22730" cap="rnd">
             <a:solidFill>
               <a:srgbClr val="111111"/>
             </a:solidFill>

</xml_diff>